<commit_message>
Form 3 L9-L11: align titles and content with the syllabus
L9 The Theories of the Earth's Structure: Continental Drift (main idea,
illustration of drifting, evidence); L10 Plate Tectonics (definition,
geometric and kinetic ideas, plates, margins and landforms); L11 Volcanoes
(definition and origin, types, processes and general structure). New
diagrams: break-up of Pangaea, volcano types, intrusive/extrusive features.

Co-Authored-By: Claude Opus 5.5 <noreply@anthropic.com>
Claude-Session: https://claude.ai/code/session_0115LFSb2ktGLWPeVksFkSer
</commit_message>
<xml_diff>
--- a/lecons/F3/11_FORM4_LESSON08_Rocks.pptx
+++ b/lecons/F3/11_FORM4_LESSON08_Rocks.pptx
@@ -3627,7 +3627,7 @@
           <a:p>
             <a:r>
               <a:rPr lang="en-US" dirty="0"/>
-              <a:t>Our next lesson will be on Lesson 9: The Theory of Continental Drift. Thank you for your attention, and see you next time.</a:t>
+              <a:t>Our next lesson will be on Lesson 9: The Theories of the Earth's Structure: Continental Drift. Thank you for your attention, and see you next time.</a:t>
             </a:r>
             <a:endParaRPr lang="en-US" dirty="0"/>
           </a:p>
@@ -14928,7 +14928,7 @@
                 <a:ea typeface="Times New Roman" pitchFamily="34" charset="-122"/>
                 <a:cs typeface="Times New Roman" pitchFamily="34" charset="-120"/>
               </a:rPr>
-              <a:t>Lesson 9: The Theory of Continental Drift</a:t>
+              <a:t>Lesson 9: The Theories of the Earth's Structure: Continental Drift</a:t>
             </a:r>
             <a:endParaRPr lang="en-US" sz="4000" dirty="0"/>
           </a:p>

</xml_diff>